<commit_message>
docs: credit team members Prashant Gautam, Prathvi Goswami, Ankit Kumar, and Love Gwal across all pitch decks and documentation
</commit_message>
<xml_diff>
--- a/AarogyaVani_Presentation.pptx
+++ b/AarogyaVani_Presentation.pptx
@@ -3931,13 +3931,13 @@
             <a:pPr algn="ctr">
               <a:defRPr sz="1100" b="1">
                 <a:solidFill>
-                  <a:srgbClr val="94A3B8"/>
+                  <a:srgbClr val="E2E8F0"/>
                 </a:solidFill>
                 <a:latin typeface="Segoe UI"/>
               </a:defRPr>
             </a:pPr>
             <a:r>
-              <a:t>Team LocalHost Boys • GDG HBTU   |   React 19 • Gemini 2.5 Flash • Sarvam AI   |   Production Ready PWA</a:t>
+              <a:t>Team LocalHost Boys (GDG HBTU): Prashant Gautam • Prathvi Goswami • Ankit Kumar • Love Gwal</a:t>
             </a:r>
           </a:p>
         </p:txBody>

</xml_diff>